<commit_message>
Correct MTTR claims to measured ~46s LLM agentic number
- Headline now ~46s (LLM agentic swarm on Ollama) vs 42min baseline = ~98% reduction, ~52x
- Keep ~1.1s clearly labeled as the rule-engine fallback path in benchmark docs
- Update BENCHMARK_REPORT, CONTEXT, FEATURES, PRESENTATION_SCRIPT, deck script,
  memory seed data, and the round-2 pptx (slides 3 + 8)
</commit_message>
<xml_diff>
--- a/TUESDAY_Round2_Presentation.pptx
+++ b/TUESDAY_Round2_Presentation.pptx
@@ -4780,7 +4780,7 @@
 2. Tool-Grounded ReAct Loop: Agents must call Sigma/YARA/IOC tools before voting - zero hallucinations.
 3. Weighted Consensus and Safety Gate: 8 agents vote with confidence; risk &gt; 80 auto-escalates to human queue.
 4. Adaptive Episodic Memory: Remembers past incidents and synthesizes self-learning playbooks.
-5. 99.9% MTTR Reduction: Investigation and response in ~1.1 seconds vs 40+ mins manually.</a:t>
+5. ~98% MTTR Reduction: Investigation and response in ~46 seconds vs 40+ mins manually.</a:t>
             </a:r>
           </a:p>
         </p:txBody>
@@ -6821,7 +6821,7 @@
                 </a:solidFill>
                 <a:latin typeface="Segoe UI" panose="020B0502040204020203" pitchFamily="34" charset="0"/>
               </a:rPr>
-              <a:t>- Quantified Business Impact: Reduces MTTR from ~42 mins to ~1.11 seconds (99.9% reduction). Saves + annually in SOAR licensing and Tier-1 triage costs.
+              <a:t>- Quantified Business Impact: Reduces MTTR from ~42 mins to ~46 seconds (~98% reduction). Saves + annually in SOAR licensing and Tier-1 triage costs.
 - Social Impact: Democratizes enterprise-grade AI defense for underfunded public sector orgs, schools and SMBs. Keeps sensitive security telemetry 100% local.</a:t>
             </a:r>
           </a:p>

</xml_diff>